<commit_message>
feat: replace Azure RAG providers with Qdrant and MinIO
</commit_message>
<xml_diff>
--- a/docs/Presentation_BaoCao_TotNghiep_NEXTGEN.pptx
+++ b/docs/Presentation_BaoCao_TotNghiep_NEXTGEN.pptx
@@ -3896,7 +3896,7 @@
                 </a:solidFill>
                 <a:latin typeface="Noto Sans"/>
               </a:rPr>
-              <a:t>Nguyên tắc xuyên suốt mọi advisor và workflow</a:t>
+              <a:t>DeepSeek V4 Pro · strict JSON · human approval</a:t>
             </a:r>
           </a:p>
         </p:txBody>
@@ -7982,7 +7982,7 @@
                 </a:solidFill>
                 <a:latin typeface="Noto Sans"/>
               </a:rPr>
-              <a:t>RAG PIPELINE: PRIVATE BLOB → MINERU → BGE-M3 → AZURE AI SEARCH → ACL FILTER</a:t>
+              <a:t>RAG: PRIVATE MINIO → MINERU → BGE-M3 → QDRANT DENSE VECTOR → TYPED ACL → SQL RECHECK</a:t>
             </a:r>
           </a:p>
         </p:txBody>
@@ -10851,7 +10851,7 @@
                 </a:solidFill>
                 <a:latin typeface="Noto Sans"/>
               </a:rPr>
-              <a:t>563/563</a:t>
+              <a:t>586/586</a:t>
             </a:r>
           </a:p>
         </p:txBody>

</xml_diff>